<commit_message>
fix(handouts): generalize workshop branding and release artifacts
- Preserve Fabric environment and Data Agent guidance
- Rebuild anonymized screenshots, decks and release bundles

🔒 - Generated by Copilot
</commit_message>
<xml_diff>
--- a/decks/woodlands-manual-workshop.pptx
+++ b/decks/woodlands-manual-workshop.pptx
@@ -1130,7 +1130,7 @@
           <a:p/>
           <a:p>
             <a:r>
-              <a:t>1. Return to your learner folder in the `jdi-training-manual` workspace.</a:t>
+              <a:t>1. Return to your learner folder in the `fabric-training-manual` workspace.</a:t>
             </a:r>
           </a:p>
           <a:p>
@@ -1270,7 +1270,7 @@
           <a:p/>
           <a:p>
             <a:r>
-              <a:t>1. Return to your learner folder in the `jdi-training-manual` workspace.</a:t>
+              <a:t>1. Return to your learner folder in the `fabric-training-manual` workspace.</a:t>
             </a:r>
           </a:p>
           <a:p>
@@ -1477,7 +1477,7 @@
           </a:p>
           <a:p>
             <a:r>
-              <a:t>5. Select the `env_forestops` row whose **Location** is exactly `jdi-training-manual`,</a:t>
+              <a:t>5. Select the `env_forestops` row whose **Location** is exactly `fabric-training-manual`,</a:t>
             </a:r>
           </a:p>
           <a:p>
@@ -1497,7 +1497,7 @@
           </a:p>
           <a:p>
             <a:r>
-              <a:t>7. Filter to `lh_woodlands_demo`. Select the **Lakehouse** row in `jdi-training-manual`,</a:t>
+              <a:t>7. Filter to `lh_woodlands_demo`. Select the **Lakehouse** row in `fabric-training-manual`,</a:t>
             </a:r>
           </a:p>
           <a:p>
@@ -1547,7 +1547,7 @@
           </a:p>
           <a:p>
             <a:r>
-              <a:t>   `WORKSPACE = "jdi-training-manual"` and `LAKEHOUSE = "lh_woodlands_demo"`.</a:t>
+              <a:t>   `WORKSPACE = "fabric-training-manual"` and `LAKEHOUSE = "lh_woodlands_demo"`.</a:t>
             </a:r>
           </a:p>
           <a:p>
@@ -1558,7 +1558,7 @@
           <a:p/>
           <a:p>
             <a:r>
-              <a:t>![Choose env_forestops from the jdi-training-manual workspace.](images/training/manual/13-environment-picker.png)</a:t>
+              <a:t>![Choose env_forestops from the fabric-training-manual workspace.](images/training/manual/13-environment-picker.png)</a:t>
             </a:r>
           </a:p>
           <a:p/>
@@ -1746,7 +1746,7 @@
           </a:p>
           <a:p>
             <a:r>
-              <a:t>5. Select the `env_forestops` row whose **Location** is exactly `jdi-training-manual`,</a:t>
+              <a:t>5. Select the `env_forestops` row whose **Location** is exactly `fabric-training-manual`,</a:t>
             </a:r>
           </a:p>
           <a:p>
@@ -1766,7 +1766,7 @@
           </a:p>
           <a:p>
             <a:r>
-              <a:t>7. Filter to `lh_woodlands_demo`. Select the **Lakehouse** row in `jdi-training-manual`,</a:t>
+              <a:t>7. Filter to `lh_woodlands_demo`. Select the **Lakehouse** row in `fabric-training-manual`,</a:t>
             </a:r>
           </a:p>
           <a:p>
@@ -1816,7 +1816,7 @@
           </a:p>
           <a:p>
             <a:r>
-              <a:t>   `WORKSPACE = "jdi-training-manual"` and `LAKEHOUSE = "lh_woodlands_demo"`.</a:t>
+              <a:t>   `WORKSPACE = "fabric-training-manual"` and `LAKEHOUSE = "lh_woodlands_demo"`.</a:t>
             </a:r>
           </a:p>
           <a:p>
@@ -1827,7 +1827,7 @@
           <a:p/>
           <a:p>
             <a:r>
-              <a:t>![Choose env_forestops from the jdi-training-manual workspace.](images/training/manual/13-environment-picker.png)</a:t>
+              <a:t>![Choose env_forestops from the fabric-training-manual workspace.](images/training/manual/13-environment-picker.png)</a:t>
             </a:r>
           </a:p>
           <a:p/>
@@ -2015,7 +2015,7 @@
           </a:p>
           <a:p>
             <a:r>
-              <a:t>5. Select the `env_forestops` row whose **Location** is exactly `jdi-training-manual`,</a:t>
+              <a:t>5. Select the `env_forestops` row whose **Location** is exactly `fabric-training-manual`,</a:t>
             </a:r>
           </a:p>
           <a:p>
@@ -2035,7 +2035,7 @@
           </a:p>
           <a:p>
             <a:r>
-              <a:t>7. Filter to `lh_woodlands_demo`. Select the **Lakehouse** row in `jdi-training-manual`,</a:t>
+              <a:t>7. Filter to `lh_woodlands_demo`. Select the **Lakehouse** row in `fabric-training-manual`,</a:t>
             </a:r>
           </a:p>
           <a:p>
@@ -2085,7 +2085,7 @@
           </a:p>
           <a:p>
             <a:r>
-              <a:t>   `WORKSPACE = "jdi-training-manual"` and `LAKEHOUSE = "lh_woodlands_demo"`.</a:t>
+              <a:t>   `WORKSPACE = "fabric-training-manual"` and `LAKEHOUSE = "lh_woodlands_demo"`.</a:t>
             </a:r>
           </a:p>
           <a:p>
@@ -2096,7 +2096,7 @@
           <a:p/>
           <a:p>
             <a:r>
-              <a:t>![Choose env_forestops from the jdi-training-manual workspace.](images/training/manual/13-environment-picker.png)</a:t>
+              <a:t>![Choose env_forestops from the fabric-training-manual workspace.](images/training/manual/13-environment-picker.png)</a:t>
             </a:r>
           </a:p>
           <a:p/>
@@ -2284,7 +2284,7 @@
           </a:p>
           <a:p>
             <a:r>
-              <a:t>5. Select the `env_forestops` row whose **Location** is exactly `jdi-training-manual`,</a:t>
+              <a:t>5. Select the `env_forestops` row whose **Location** is exactly `fabric-training-manual`,</a:t>
             </a:r>
           </a:p>
           <a:p>
@@ -2304,7 +2304,7 @@
           </a:p>
           <a:p>
             <a:r>
-              <a:t>7. Filter to `lh_woodlands_demo`. Select the **Lakehouse** row in `jdi-training-manual`,</a:t>
+              <a:t>7. Filter to `lh_woodlands_demo`. Select the **Lakehouse** row in `fabric-training-manual`,</a:t>
             </a:r>
           </a:p>
           <a:p>
@@ -2354,7 +2354,7 @@
           </a:p>
           <a:p>
             <a:r>
-              <a:t>   `WORKSPACE = "jdi-training-manual"` and `LAKEHOUSE = "lh_woodlands_demo"`.</a:t>
+              <a:t>   `WORKSPACE = "fabric-training-manual"` and `LAKEHOUSE = "lh_woodlands_demo"`.</a:t>
             </a:r>
           </a:p>
           <a:p>
@@ -2365,7 +2365,7 @@
           <a:p/>
           <a:p>
             <a:r>
-              <a:t>![Choose env_forestops from the jdi-training-manual workspace.](images/training/manual/13-environment-picker.png)</a:t>
+              <a:t>![Choose env_forestops from the fabric-training-manual workspace.](images/training/manual/13-environment-picker.png)</a:t>
             </a:r>
           </a:p>
           <a:p/>
@@ -2666,7 +2666,7 @@
           </a:p>
           <a:p>
             <a:r>
-              <a:t>   `WORKSPACE="jdi-training-manual"` and your own lakehouse name.</a:t>
+              <a:t>   `WORKSPACE="fabric-training-manual"` and your own lakehouse name.</a:t>
             </a:r>
           </a:p>
           <a:p>
@@ -2842,7 +2842,7 @@
           </a:p>
           <a:p>
             <a:r>
-              <a:t>3. Select **Workspaces** &gt; **New workspace** and enter `jdi-training-manual`.</a:t>
+              <a:t>3. Select **Workspaces** &gt; **New workspace** and enter `fabric-training-manual`.</a:t>
             </a:r>
           </a:p>
           <a:p>
@@ -2862,7 +2862,7 @@
           </a:p>
           <a:p>
             <a:r>
-              <a:t>   the older `jdi-training` reference workspace and its items.</a:t>
+              <a:t>   the older `fabric-training` reference workspace and its items.</a:t>
             </a:r>
           </a:p>
           <a:p>
@@ -2923,7 +2923,7 @@
           <a:p/>
           <a:p>
             <a:r>
-              <a:t>![Name the facilitator workspace jdi-training-manual and open Advanced.](images/training/manual/01-workspace-create.png)</a:t>
+              <a:t>![Name the facilitator workspace fabric-training-manual and open Advanced.](images/training/manual/01-workspace-create.png)</a:t>
             </a:r>
           </a:p>
           <a:p/>
@@ -3032,7 +3032,7 @@
           </a:p>
           <a:p>
             <a:r>
-              <a:t>   `WORKSPACE="jdi-training-manual"` and your own lakehouse name.</a:t>
+              <a:t>   `WORKSPACE="fabric-training-manual"` and your own lakehouse name.</a:t>
             </a:r>
           </a:p>
           <a:p>
@@ -4829,7 +4829,7 @@
           </a:p>
           <a:p>
             <a:r>
-              <a:t>3. Select **Workspaces** &gt; **New workspace** and enter `jdi-training-manual`.</a:t>
+              <a:t>3. Select **Workspaces** &gt; **New workspace** and enter `fabric-training-manual`.</a:t>
             </a:r>
           </a:p>
           <a:p>
@@ -4849,7 +4849,7 @@
           </a:p>
           <a:p>
             <a:r>
-              <a:t>   the older `jdi-training` reference workspace and its items.</a:t>
+              <a:t>   the older `fabric-training` reference workspace and its items.</a:t>
             </a:r>
           </a:p>
           <a:p>
@@ -4910,7 +4910,7 @@
           <a:p/>
           <a:p>
             <a:r>
-              <a:t>![Name the facilitator workspace jdi-training-manual and open Advanced.](images/training/manual/01-workspace-create.png)</a:t>
+              <a:t>![Name the facilitator workspace fabric-training-manual and open Advanced.](images/training/manual/01-workspace-create.png)</a:t>
             </a:r>
           </a:p>
           <a:p/>
@@ -5684,7 +5684,7 @@
           <a:p/>
           <a:p>
             <a:r>
-              <a:t>![Select the Lakehouse from jdi-training-manual and add it to the Map.](images/training/manual/27-map-lakehouse.png)</a:t>
+              <a:t>![Select the Lakehouse from fabric-training-manual and add it to the Map.](images/training/manual/27-map-lakehouse.png)</a:t>
             </a:r>
           </a:p>
           <a:p/>
@@ -5835,7 +5835,7 @@
           <a:p/>
           <a:p>
             <a:r>
-              <a:t>![Select the Lakehouse from jdi-training-manual and add it to the Map.](images/training/manual/27-map-lakehouse.png)</a:t>
+              <a:t>![Select the Lakehouse from fabric-training-manual and add it to the Map.](images/training/manual/27-map-lakehouse.png)</a:t>
             </a:r>
           </a:p>
           <a:p/>
@@ -5986,7 +5986,7 @@
           <a:p/>
           <a:p>
             <a:r>
-              <a:t>![Select the Lakehouse from jdi-training-manual and add it to the Map.](images/training/manual/27-map-lakehouse.png)</a:t>
+              <a:t>![Select the Lakehouse from fabric-training-manual and add it to the Map.](images/training/manual/27-map-lakehouse.png)</a:t>
             </a:r>
           </a:p>
           <a:p/>
@@ -7294,7 +7294,7 @@
           <a:p/>
           <a:p>
             <a:r>
-              <a:t>1. Open the Contoso workspace `jdi-training-manual`. Confirm its assigned</a:t>
+              <a:t>1. Open the Contoso workspace `fabric-training-manual`. Confirm its assigned</a:t>
             </a:r>
           </a:p>
           <a:p>
@@ -10421,12 +10421,12 @@
           </a:p>
           <a:p>
             <a:r>
-              <a:t>2. Select **Workspaces** &gt; **jdi-training-manual**. Check the workspace name.</a:t>
-            </a:r>
-          </a:p>
-          <a:p>
-            <a:r>
-              <a:t>   Leave the older `jdi-training` reference workspace and its results unchanged.</a:t>
+              <a:t>2. Select **Workspaces** &gt; **fabric-training-manual**. Check the workspace name.</a:t>
+            </a:r>
+          </a:p>
+          <a:p>
+            <a:r>
+              <a:t>   Leave the older `fabric-training` reference workspace and its results unchanged.</a:t>
             </a:r>
           </a:p>
           <a:p>
@@ -13980,7 +13980,7 @@
               </a:defRPr>
             </a:pPr>
             <a:r>
-              <a:t>JDI WOODLANDS | MANUAL FABRIC WORKSHOP</a:t>
+              <a:t>WOODLANDS | MANUAL FABRIC WORKSHOP</a:t>
             </a:r>
           </a:p>
         </p:txBody>
@@ -16375,7 +16375,7 @@
               </a:defRPr>
             </a:pPr>
             <a:r>
-              <a:t>Verify Location is jdi-training-manual, not one of the reference workspaces.</a:t>
+              <a:t>Verify Location is fabric-training-manual, not one of the reference workspaces.</a:t>
             </a:r>
           </a:p>
         </p:txBody>
@@ -18913,7 +18913,7 @@
               </a:defRPr>
             </a:pPr>
             <a:r>
-              <a:t>Use jdi-training-manual for this rehearsal.</a:t>
+              <a:t>Use fabric-training-manual for this rehearsal.</a:t>
             </a:r>
           </a:p>
         </p:txBody>
@@ -25557,7 +25557,7 @@
               </a:defRPr>
             </a:pPr>
             <a:r>
-              <a:t>Confirm Location is jdi-training-manual.</a:t>
+              <a:t>Confirm Location is fabric-training-manual.</a:t>
             </a:r>
           </a:p>
         </p:txBody>

</xml_diff>